<commit_message>
feat: switch Twilio auth to API Keys and update exec deck
- send-otp, verify-otp: replace TWILIO_AUTH_TOKEN with TWILIO_API_KEY_SID
  + TWILIO_API_KEY_SECRET (Standard key — least privilege, independently
  revocable without affecting other integrations)
- supabase/functions/deno.json: add Deno compiler config to silence false
  VS Code TypeScript diagnostics on Deno runtime files
- docs/GullyCricketScorer_Executive.pptx: rebrand to Inningsly throughout,
  update Phase 2 roadmap (auth, RBAC, commentary, RevenueCat), Phase 3
  (DLS, charts), tech stack (Twilio Verify, Turnstile), security slide,
  and By the Numbers (9 cloud tables)
- docs/expert-panel-review.html: new standalone expert panel review page

Co-Authored-By: Claude Sonnet 4.6 <noreply@anthropic.com>
</commit_message>
<xml_diff>
--- a/docs/GullyCricketScorer_Executive.pptx
+++ b/docs/GullyCricketScorer_Executive.pptx
@@ -3378,8 +3378,7 @@
                   <a:srgbClr val="FFFFFF"/>
                 </a:solidFill>
               </a:rPr>
-              <a:t>Gully Cricket
-Scorer</a:t>
+              <a:t>Inningsly</a:t>
             </a:r>
           </a:p>
         </p:txBody>
@@ -3447,7 +3446,7 @@
                   <a:srgbClr val="A8DBAB"/>
                 </a:solidFill>
               </a:rPr>
-              <a:t>March 2026</a:t>
+              <a:t>April 2026</a:t>
             </a:r>
           </a:p>
         </p:txBody>
@@ -3517,8 +3516,7 @@
                 </a:solidFill>
               </a:rPr>
               <a:t>A professional-grade cricket scoring platform
-for Android, iOS and Web — built for gully cricket,
-powered by real-time cloud technology.</a:t>
+for Android, iOS and Web — built for community cricket, with phone-based accounts, real-time cloud, and monetisation-ready plans.</a:t>
             </a:r>
           </a:p>
         </p:txBody>
@@ -5653,9 +5651,7 @@
                   <a:srgbClr val="555555"/>
                 </a:solidFill>
               </a:rPr>
-              <a:t>Team admin PINs hashed with SHA-256 via expo-crypto before storage.
-Plaintext never stored in SQLite or transmitted to cloud.
-Auth state held in-memory only — clears on app restart by design.</a:t>
+              <a:t>Admin PINs and user PINs hashed with SHA-256 via expo-crypto. User PIN verified server-side via Supabase RPC (SECURITY DEFINER) — hash never returned to client. In-memory auth clears on app restart by design.</a:t>
             </a:r>
           </a:p>
         </p:txBody>
@@ -6612,9 +6608,7 @@
                   <a:srgbClr val="555555"/>
                 </a:solidFill>
               </a:rPr>
-              <a:t>Player names and match data are never sent to Anthropic or any third party.
-Phone numbers are optional and stored locally only.
-Cloud tables contain only team metadata and live match scores.</a:t>
+              <a:t>Phone is the primary identity — stored locally + Supabase user_profiles (phone, name, PIN hash only). OTP via Twilio Verify; bots blocked by Cloudflare Turnstile + country-prefix allowlist. Match data and player names are never sent to third parties.</a:t>
             </a:r>
           </a:p>
         </p:txBody>
@@ -7750,7 +7744,7 @@
                   <a:srgbClr val="FFFFFF"/>
                 </a:solidFill>
               </a:rPr>
-              <a:t>Cloud &amp; Community</a:t>
+              <a:t>Cloud, Auth &amp; Growth</a:t>
             </a:r>
           </a:p>
         </p:txBody>
@@ -8291,7 +8285,7 @@
                   <a:srgbClr val="1A1A1A"/>
                 </a:solidFill>
               </a:rPr>
-              <a:t>Admin PIN (SHA-256)</a:t>
+              <a:t>Admin PIN (SHA-256) + User PIN (server-verified RPC)</a:t>
             </a:r>
           </a:p>
         </p:txBody>
@@ -8368,7 +8362,7 @@
                   <a:srgbClr val="1A1A1A"/>
                 </a:solidFill>
               </a:rPr>
-              <a:t>Dark mode + MD3 theme</a:t>
+              <a:t>Dark mode + MD3 theme + responsive tablet layout</a:t>
             </a:r>
           </a:p>
         </p:txBody>
@@ -8445,7 +8439,7 @@
                   <a:srgbClr val="1A1A1A"/>
                 </a:solidFill>
               </a:rPr>
-              <a:t>Expo Router navigation</a:t>
+              <a:t>Expo Router navigation + marketing landing page (web)</a:t>
             </a:r>
           </a:p>
         </p:txBody>
@@ -8834,7 +8828,7 @@
                   <a:srgbClr val="1A1A1A"/>
                 </a:solidFill>
               </a:rPr>
-              <a:t>Match commentary sharing</a:t>
+              <a:t>Wagon wheel + Manhattan plot charts</a:t>
             </a:r>
           </a:p>
         </p:txBody>
@@ -9065,7 +9059,7 @@
                   <a:srgbClr val="1A1A1A"/>
                 </a:solidFill>
               </a:rPr>
-              <a:t>Landscape scorecard view</a:t>
+              <a:t>Interactive match timeline (worm chart)</a:t>
             </a:r>
           </a:p>
         </p:txBody>
@@ -9296,7 +9290,7 @@
                   <a:srgbClr val="1A1A1A"/>
                 </a:solidFill>
               </a:rPr>
-              <a:t>EAS app store submission</a:t>
+              <a:t>DLS (Duckworth-Lewis-Stern) calculations</a:t>
             </a:r>
           </a:p>
         </p:txBody>
@@ -9511,8 +9505,7 @@
                   <a:srgbClr val="FFFFFF"/>
                 </a:solidFill>
               </a:rPr>
-              <a:t>Gully Cricket
-Scorer</a:t>
+              <a:t>Inningsly</a:t>
             </a:r>
           </a:p>
         </p:txBody>
@@ -9750,7 +9743,7 @@
                   <a:srgbClr val="FFFFFF"/>
                 </a:solidFill>
               </a:rPr>
-              <a:t>✅  Open-source stack — zero licensing cost</a:t>
+              <a:t>✅  Monetisation-ready: free / pro / league plans (RevenueCat)</a:t>
             </a:r>
           </a:p>
         </p:txBody>
@@ -10428,7 +10421,7 @@
                   <a:srgbClr val="1B6B28"/>
                 </a:solidFill>
               </a:rPr>
-              <a:t>5</a:t>
+              <a:t>9</a:t>
             </a:r>
           </a:p>
         </p:txBody>
@@ -12120,7 +12113,7 @@
                   <a:srgbClr val="A8DBAB"/>
                 </a:solidFill>
               </a:rPr>
-              <a:t>Gully Cricket Scorer — one app, every format, everywhere</a:t>
+              <a:t>Inningsly — one app, every format, everywhere</a:t>
             </a:r>
           </a:p>
         </p:txBody>
@@ -12154,7 +12147,7 @@
                   <a:srgbClr val="1A1A1A"/>
                 </a:solidFill>
               </a:rPr>
-              <a:t>Gully Cricket Scorer is a professional-grade, offline-first scoring platform built for street and community cricket. It handles every format from T20 to Test, stores complete match history, and broadcasts live scores to spectators within 50 miles — all without requiring a backend subscription or user accounts.</a:t>
+              <a:t>Inningsly is a professional-grade, offline-first scoring platform built for street and community cricket. It handles every format from T20 to Test, stores complete match history, and broadcasts live scores to spectators within 50 miles — with lightweight phone-number accounts that restore seamlessly across devices.</a:t>
             </a:r>
           </a:p>
         </p:txBody>
@@ -15263,9 +15256,7 @@
                   <a:srgbClr val="B0BEC5"/>
                 </a:solidFill>
               </a:rPr>
-              <a:t>Real-time live scores, team chat,
-delegate codes. Row-level security.
-Optional — app works without it.</a:t>
+              <a:t>Live scores, chat, delegate codes. OTP auth via Twilio Verify. Bot protection via Cloudflare Turnstile. RLS + graceful degradation.</a:t>
             </a:r>
           </a:p>
         </p:txBody>
@@ -15455,9 +15446,7 @@
                   <a:srgbClr val="B0BEC5"/>
                 </a:solidFill>
               </a:rPr>
-              <a:t>Pure engine unit tests + 99
-functional end-to-end scenarios.
-All cricket rules validated.</a:t>
+              <a:t>Pure engine unit tests + 99 functional scenarios. All cricket rules validated. In-app purchases via RevenueCat (free / pro / league).</a:t>
             </a:r>
           </a:p>
         </p:txBody>

</xml_diff>